<commit_message>
Sevone config select chat updated
</commit_message>
<xml_diff>
--- a/Presentation1.pptx
+++ b/Presentation1.pptx
@@ -6,6 +6,7 @@
   </p:sldMasterIdLst>
   <p:sldIdLst>
     <p:sldId id="256" r:id="rId2"/>
+    <p:sldId id="257" r:id="rId3"/>
   </p:sldIdLst>
   <p:sldSz cx="12192000" cy="6858000"/>
   <p:notesSz cx="6858000" cy="9144000"/>
@@ -104,6 +105,11 @@
       </a:defRPr>
     </a:lvl9pPr>
   </p:defaultTextStyle>
+  <p:extLst>
+    <p:ext uri="{EFAFB233-063F-42B5-8137-9DF3F51BA10A}">
+      <p15:sldGuideLst xmlns:p15="http://schemas.microsoft.com/office/powerpoint/2012/main"/>
+    </p:ext>
+  </p:extLst>
 </p:presentation>
 </file>
 
@@ -256,7 +262,7 @@
           <a:p>
             <a:fld id="{779E0FFE-8F3F-DF47-876C-03A89756FF9C}" type="datetimeFigureOut">
               <a:rPr lang="en-US" smtClean="0"/>
-              <a:t>4/29/26</a:t>
+              <a:t>5/4/26</a:t>
             </a:fld>
             <a:endParaRPr lang="en-US"/>
           </a:p>
@@ -456,7 +462,7 @@
           <a:p>
             <a:fld id="{779E0FFE-8F3F-DF47-876C-03A89756FF9C}" type="datetimeFigureOut">
               <a:rPr lang="en-US" smtClean="0"/>
-              <a:t>4/29/26</a:t>
+              <a:t>5/4/26</a:t>
             </a:fld>
             <a:endParaRPr lang="en-US"/>
           </a:p>
@@ -666,7 +672,7 @@
           <a:p>
             <a:fld id="{779E0FFE-8F3F-DF47-876C-03A89756FF9C}" type="datetimeFigureOut">
               <a:rPr lang="en-US" smtClean="0"/>
-              <a:t>4/29/26</a:t>
+              <a:t>5/4/26</a:t>
             </a:fld>
             <a:endParaRPr lang="en-US"/>
           </a:p>
@@ -866,7 +872,7 @@
           <a:p>
             <a:fld id="{779E0FFE-8F3F-DF47-876C-03A89756FF9C}" type="datetimeFigureOut">
               <a:rPr lang="en-US" smtClean="0"/>
-              <a:t>4/29/26</a:t>
+              <a:t>5/4/26</a:t>
             </a:fld>
             <a:endParaRPr lang="en-US"/>
           </a:p>
@@ -1142,7 +1148,7 @@
           <a:p>
             <a:fld id="{779E0FFE-8F3F-DF47-876C-03A89756FF9C}" type="datetimeFigureOut">
               <a:rPr lang="en-US" smtClean="0"/>
-              <a:t>4/29/26</a:t>
+              <a:t>5/4/26</a:t>
             </a:fld>
             <a:endParaRPr lang="en-US"/>
           </a:p>
@@ -1410,7 +1416,7 @@
           <a:p>
             <a:fld id="{779E0FFE-8F3F-DF47-876C-03A89756FF9C}" type="datetimeFigureOut">
               <a:rPr lang="en-US" smtClean="0"/>
-              <a:t>4/29/26</a:t>
+              <a:t>5/4/26</a:t>
             </a:fld>
             <a:endParaRPr lang="en-US"/>
           </a:p>
@@ -1825,7 +1831,7 @@
           <a:p>
             <a:fld id="{779E0FFE-8F3F-DF47-876C-03A89756FF9C}" type="datetimeFigureOut">
               <a:rPr lang="en-US" smtClean="0"/>
-              <a:t>4/29/26</a:t>
+              <a:t>5/4/26</a:t>
             </a:fld>
             <a:endParaRPr lang="en-US"/>
           </a:p>
@@ -1967,7 +1973,7 @@
           <a:p>
             <a:fld id="{779E0FFE-8F3F-DF47-876C-03A89756FF9C}" type="datetimeFigureOut">
               <a:rPr lang="en-US" smtClean="0"/>
-              <a:t>4/29/26</a:t>
+              <a:t>5/4/26</a:t>
             </a:fld>
             <a:endParaRPr lang="en-US"/>
           </a:p>
@@ -2080,7 +2086,7 @@
           <a:p>
             <a:fld id="{779E0FFE-8F3F-DF47-876C-03A89756FF9C}" type="datetimeFigureOut">
               <a:rPr lang="en-US" smtClean="0"/>
-              <a:t>4/29/26</a:t>
+              <a:t>5/4/26</a:t>
             </a:fld>
             <a:endParaRPr lang="en-US"/>
           </a:p>
@@ -2393,7 +2399,7 @@
           <a:p>
             <a:fld id="{779E0FFE-8F3F-DF47-876C-03A89756FF9C}" type="datetimeFigureOut">
               <a:rPr lang="en-US" smtClean="0"/>
-              <a:t>4/29/26</a:t>
+              <a:t>5/4/26</a:t>
             </a:fld>
             <a:endParaRPr lang="en-US"/>
           </a:p>
@@ -2682,7 +2688,7 @@
           <a:p>
             <a:fld id="{779E0FFE-8F3F-DF47-876C-03A89756FF9C}" type="datetimeFigureOut">
               <a:rPr lang="en-US" smtClean="0"/>
-              <a:t>4/29/26</a:t>
+              <a:t>5/4/26</a:t>
             </a:fld>
             <a:endParaRPr lang="en-US"/>
           </a:p>
@@ -2925,7 +2931,7 @@
           <a:p>
             <a:fld id="{779E0FFE-8F3F-DF47-876C-03A89756FF9C}" type="datetimeFigureOut">
               <a:rPr lang="en-US" smtClean="0"/>
-              <a:t>4/29/26</a:t>
+              <a:t>5/4/26</a:t>
             </a:fld>
             <a:endParaRPr lang="en-US"/>
           </a:p>
@@ -3342,6 +3348,108 @@
           <a:chExt cx="0" cy="0"/>
         </a:xfrm>
       </p:grpSpPr>
+      <p:sp>
+        <p:nvSpPr>
+          <p:cNvPr id="2" name="Rectangle 1">
+            <a:extLst>
+              <a:ext uri="{FF2B5EF4-FFF2-40B4-BE49-F238E27FC236}">
+                <a16:creationId xmlns:a16="http://schemas.microsoft.com/office/drawing/2014/main" id="{E3A9712F-A92A-1189-F14F-EB8A41F854C6}"/>
+              </a:ext>
+            </a:extLst>
+          </p:cNvPr>
+          <p:cNvSpPr/>
+          <p:nvPr/>
+        </p:nvSpPr>
+        <p:spPr>
+          <a:xfrm>
+            <a:off x="4115140" y="3234076"/>
+            <a:ext cx="4847765" cy="3383610"/>
+          </a:xfrm>
+          <a:prstGeom prst="rect">
+            <a:avLst/>
+          </a:prstGeom>
+          <a:solidFill>
+            <a:schemeClr val="accent1">
+              <a:alpha val="45958"/>
+            </a:schemeClr>
+          </a:solidFill>
+        </p:spPr>
+        <p:style>
+          <a:lnRef idx="2">
+            <a:schemeClr val="accent1">
+              <a:shade val="15000"/>
+            </a:schemeClr>
+          </a:lnRef>
+          <a:fillRef idx="1">
+            <a:schemeClr val="accent1"/>
+          </a:fillRef>
+          <a:effectRef idx="0">
+            <a:schemeClr val="accent1"/>
+          </a:effectRef>
+          <a:fontRef idx="minor">
+            <a:schemeClr val="lt1"/>
+          </a:fontRef>
+        </p:style>
+        <p:txBody>
+          <a:bodyPr rtlCol="0" anchor="ctr"/>
+          <a:lstStyle/>
+          <a:p>
+            <a:pPr algn="ctr"/>
+            <a:endParaRPr lang="en-US" dirty="0"/>
+          </a:p>
+        </p:txBody>
+      </p:sp>
+      <p:sp>
+        <p:nvSpPr>
+          <p:cNvPr id="4" name="Rectangle 3">
+            <a:extLst>
+              <a:ext uri="{FF2B5EF4-FFF2-40B4-BE49-F238E27FC236}">
+                <a16:creationId xmlns:a16="http://schemas.microsoft.com/office/drawing/2014/main" id="{7CBD6AC7-3AEA-6EB0-C41E-8BC946ADC6A2}"/>
+              </a:ext>
+            </a:extLst>
+          </p:cNvPr>
+          <p:cNvSpPr/>
+          <p:nvPr/>
+        </p:nvSpPr>
+        <p:spPr>
+          <a:xfrm>
+            <a:off x="4115140" y="681400"/>
+            <a:ext cx="4764476" cy="2408238"/>
+          </a:xfrm>
+          <a:prstGeom prst="rect">
+            <a:avLst/>
+          </a:prstGeom>
+          <a:solidFill>
+            <a:schemeClr val="accent1">
+              <a:alpha val="45958"/>
+            </a:schemeClr>
+          </a:solidFill>
+        </p:spPr>
+        <p:style>
+          <a:lnRef idx="2">
+            <a:schemeClr val="accent1">
+              <a:shade val="15000"/>
+            </a:schemeClr>
+          </a:lnRef>
+          <a:fillRef idx="1">
+            <a:schemeClr val="accent1"/>
+          </a:fillRef>
+          <a:effectRef idx="0">
+            <a:schemeClr val="accent1"/>
+          </a:effectRef>
+          <a:fontRef idx="minor">
+            <a:schemeClr val="lt1"/>
+          </a:fontRef>
+        </p:style>
+        <p:txBody>
+          <a:bodyPr rtlCol="0" anchor="ctr"/>
+          <a:lstStyle/>
+          <a:p>
+            <a:pPr algn="ctr"/>
+            <a:endParaRPr lang="en-US" dirty="0"/>
+          </a:p>
+        </p:txBody>
+      </p:sp>
       <p:cxnSp>
         <p:nvCxnSpPr>
           <p:cNvPr id="5" name="Straight Arrow Connector 4">
@@ -3356,7 +3464,7 @@
         </p:nvCxnSpPr>
         <p:spPr>
           <a:xfrm>
-            <a:off x="2817628" y="2530549"/>
+            <a:off x="2806995" y="2343266"/>
             <a:ext cx="1456660" cy="0"/>
           </a:xfrm>
           <a:prstGeom prst="straightConnector1">
@@ -3395,7 +3503,7 @@
         </p:nvSpPr>
         <p:spPr>
           <a:xfrm>
-            <a:off x="1275907" y="2222205"/>
+            <a:off x="1296407" y="2090718"/>
             <a:ext cx="1531088" cy="648586"/>
           </a:xfrm>
           <a:prstGeom prst="rect">
@@ -3444,8 +3552,8 @@
         </p:nvSpPr>
         <p:spPr>
           <a:xfrm>
-            <a:off x="4274288" y="2206255"/>
-            <a:ext cx="1701210" cy="738945"/>
+            <a:off x="4233280" y="1973794"/>
+            <a:ext cx="2402297" cy="738945"/>
           </a:xfrm>
           <a:prstGeom prst="rect">
             <a:avLst/>
@@ -3474,7 +3582,14 @@
             <a:pPr algn="ctr"/>
             <a:r>
               <a:rPr lang="en-US" dirty="0"/>
-              <a:t>SQL Expert Agent [ Bob Mode] </a:t>
+              <a:t>SQL Expert Agent </a:t>
+            </a:r>
+          </a:p>
+          <a:p>
+            <a:pPr algn="ctr"/>
+            <a:r>
+              <a:rPr lang="en-US" dirty="0"/>
+              <a:t>[ Bob Mode] </a:t>
             </a:r>
           </a:p>
         </p:txBody>
@@ -3494,7 +3609,7 @@
         <p:spPr>
           <a:xfrm>
             <a:off x="4318591" y="833771"/>
-            <a:ext cx="1531088" cy="648586"/>
+            <a:ext cx="2316986" cy="648586"/>
           </a:xfrm>
           <a:prstGeom prst="rect">
             <a:avLst/>
@@ -3545,8 +3660,8 @@
         </p:nvCxnSpPr>
         <p:spPr>
           <a:xfrm>
-            <a:off x="5066414" y="1482357"/>
-            <a:ext cx="58479" cy="723898"/>
+            <a:off x="5434429" y="1482357"/>
+            <a:ext cx="0" cy="491437"/>
           </a:xfrm>
           <a:prstGeom prst="straightConnector1">
             <a:avLst/>
@@ -3585,7 +3700,7 @@
         <p:spPr>
           <a:xfrm>
             <a:off x="4307958" y="3388242"/>
-            <a:ext cx="1412357" cy="792109"/>
+            <a:ext cx="2414116" cy="792109"/>
           </a:xfrm>
           <a:prstGeom prst="rect">
             <a:avLst/>
@@ -3637,7 +3752,7 @@
         </p:nvSpPr>
         <p:spPr>
           <a:xfrm>
-            <a:off x="4318591" y="3919870"/>
+            <a:off x="4783986" y="3954995"/>
             <a:ext cx="1314893" cy="248074"/>
           </a:xfrm>
           <a:prstGeom prst="rect">
@@ -3672,12 +3787,370 @@
           </a:p>
         </p:txBody>
       </p:sp>
-      <p:sp>
-        <p:nvSpPr>
-          <p:cNvPr id="14" name="Rectangle 13">
-            <a:extLst>
-              <a:ext uri="{FF2B5EF4-FFF2-40B4-BE49-F238E27FC236}">
-                <a16:creationId xmlns:a16="http://schemas.microsoft.com/office/drawing/2014/main" id="{31FC1795-7113-A7BE-C542-C91AAFCC8226}"/>
+      <p:cxnSp>
+        <p:nvCxnSpPr>
+          <p:cNvPr id="17" name="Straight Arrow Connector 16">
+            <a:extLst>
+              <a:ext uri="{FF2B5EF4-FFF2-40B4-BE49-F238E27FC236}">
+                <a16:creationId xmlns:a16="http://schemas.microsoft.com/office/drawing/2014/main" id="{8076974C-F42F-4919-E125-3060C3E84D31}"/>
+              </a:ext>
+            </a:extLst>
+          </p:cNvPr>
+          <p:cNvCxnSpPr>
+            <a:cxnSpLocks/>
+          </p:cNvCxnSpPr>
+          <p:nvPr/>
+        </p:nvCxnSpPr>
+        <p:spPr>
+          <a:xfrm>
+            <a:off x="5442031" y="4203069"/>
+            <a:ext cx="0" cy="795686"/>
+          </a:xfrm>
+          <a:prstGeom prst="straightConnector1">
+            <a:avLst/>
+          </a:prstGeom>
+          <a:ln>
+            <a:tailEnd type="triangle"/>
+          </a:ln>
+        </p:spPr>
+        <p:style>
+          <a:lnRef idx="2">
+            <a:schemeClr val="accent1"/>
+          </a:lnRef>
+          <a:fillRef idx="0">
+            <a:schemeClr val="accent1"/>
+          </a:fillRef>
+          <a:effectRef idx="1">
+            <a:schemeClr val="accent1"/>
+          </a:effectRef>
+          <a:fontRef idx="minor">
+            <a:schemeClr val="tx1"/>
+          </a:fontRef>
+        </p:style>
+      </p:cxnSp>
+      <p:sp>
+        <p:nvSpPr>
+          <p:cNvPr id="20" name="Can 19">
+            <a:extLst>
+              <a:ext uri="{FF2B5EF4-FFF2-40B4-BE49-F238E27FC236}">
+                <a16:creationId xmlns:a16="http://schemas.microsoft.com/office/drawing/2014/main" id="{9252A2AE-66FE-8280-8B3B-0F9895A1E701}"/>
+              </a:ext>
+            </a:extLst>
+          </p:cNvPr>
+          <p:cNvSpPr/>
+          <p:nvPr/>
+        </p:nvSpPr>
+        <p:spPr>
+          <a:xfrm>
+            <a:off x="4267200" y="4976037"/>
+            <a:ext cx="2732568" cy="1456661"/>
+          </a:xfrm>
+          <a:prstGeom prst="can">
+            <a:avLst/>
+          </a:prstGeom>
+        </p:spPr>
+        <p:style>
+          <a:lnRef idx="2">
+            <a:schemeClr val="accent1">
+              <a:shade val="15000"/>
+            </a:schemeClr>
+          </a:lnRef>
+          <a:fillRef idx="1">
+            <a:schemeClr val="accent1"/>
+          </a:fillRef>
+          <a:effectRef idx="0">
+            <a:schemeClr val="accent1"/>
+          </a:effectRef>
+          <a:fontRef idx="minor">
+            <a:schemeClr val="lt1"/>
+          </a:fontRef>
+        </p:style>
+        <p:txBody>
+          <a:bodyPr rtlCol="0" anchor="ctr"/>
+          <a:lstStyle/>
+          <a:p>
+            <a:pPr algn="ctr"/>
+            <a:r>
+              <a:rPr lang="en-US" dirty="0"/>
+              <a:t>MARIA DB</a:t>
+            </a:r>
+          </a:p>
+        </p:txBody>
+      </p:sp>
+      <p:sp>
+        <p:nvSpPr>
+          <p:cNvPr id="21" name="TextBox 20">
+            <a:extLst>
+              <a:ext uri="{FF2B5EF4-FFF2-40B4-BE49-F238E27FC236}">
+                <a16:creationId xmlns:a16="http://schemas.microsoft.com/office/drawing/2014/main" id="{33F61FA9-0ADD-D27D-90F4-3B4586406C27}"/>
+              </a:ext>
+            </a:extLst>
+          </p:cNvPr>
+          <p:cNvSpPr txBox="1"/>
+          <p:nvPr/>
+        </p:nvSpPr>
+        <p:spPr>
+          <a:xfrm>
+            <a:off x="6027552" y="4322020"/>
+            <a:ext cx="1022940" cy="646331"/>
+          </a:xfrm>
+          <a:prstGeom prst="rect">
+            <a:avLst/>
+          </a:prstGeom>
+          <a:noFill/>
+        </p:spPr>
+        <p:txBody>
+          <a:bodyPr wrap="square" rtlCol="0">
+            <a:spAutoFit/>
+          </a:bodyPr>
+          <a:lstStyle/>
+          <a:p>
+            <a:r>
+              <a:rPr lang="en-US" dirty="0"/>
+              <a:t>Select queries</a:t>
+            </a:r>
+          </a:p>
+        </p:txBody>
+      </p:sp>
+      <p:cxnSp>
+        <p:nvCxnSpPr>
+          <p:cNvPr id="23" name="Straight Arrow Connector 22">
+            <a:extLst>
+              <a:ext uri="{FF2B5EF4-FFF2-40B4-BE49-F238E27FC236}">
+                <a16:creationId xmlns:a16="http://schemas.microsoft.com/office/drawing/2014/main" id="{02EBA294-E3DF-9411-FE6E-F168FCB08EF9}"/>
+              </a:ext>
+            </a:extLst>
+          </p:cNvPr>
+          <p:cNvCxnSpPr>
+            <a:cxnSpLocks/>
+          </p:cNvCxnSpPr>
+          <p:nvPr/>
+        </p:nvCxnSpPr>
+        <p:spPr>
+          <a:xfrm flipV="1">
+            <a:off x="5434428" y="2721936"/>
+            <a:ext cx="0" cy="666306"/>
+          </a:xfrm>
+          <a:prstGeom prst="straightConnector1">
+            <a:avLst/>
+          </a:prstGeom>
+          <a:ln>
+            <a:headEnd type="arrow" w="med" len="sm"/>
+            <a:tailEnd type="arrow"/>
+          </a:ln>
+        </p:spPr>
+        <p:style>
+          <a:lnRef idx="2">
+            <a:schemeClr val="accent1"/>
+          </a:lnRef>
+          <a:fillRef idx="0">
+            <a:schemeClr val="accent1"/>
+          </a:fillRef>
+          <a:effectRef idx="1">
+            <a:schemeClr val="accent1"/>
+          </a:effectRef>
+          <a:fontRef idx="minor">
+            <a:schemeClr val="tx1"/>
+          </a:fontRef>
+        </p:style>
+      </p:cxnSp>
+      <p:cxnSp>
+        <p:nvCxnSpPr>
+          <p:cNvPr id="25" name="Straight Arrow Connector 24">
+            <a:extLst>
+              <a:ext uri="{FF2B5EF4-FFF2-40B4-BE49-F238E27FC236}">
+                <a16:creationId xmlns:a16="http://schemas.microsoft.com/office/drawing/2014/main" id="{2DD92A26-4EB2-157F-4E43-9D4B40DC587A}"/>
+              </a:ext>
+            </a:extLst>
+          </p:cNvPr>
+          <p:cNvCxnSpPr>
+            <a:cxnSpLocks/>
+          </p:cNvCxnSpPr>
+          <p:nvPr/>
+        </p:nvCxnSpPr>
+        <p:spPr>
+          <a:xfrm flipH="1">
+            <a:off x="2806995" y="2592189"/>
+            <a:ext cx="1456660" cy="0"/>
+          </a:xfrm>
+          <a:prstGeom prst="straightConnector1">
+            <a:avLst/>
+          </a:prstGeom>
+          <a:ln>
+            <a:tailEnd type="triangle"/>
+          </a:ln>
+        </p:spPr>
+        <p:style>
+          <a:lnRef idx="2">
+            <a:schemeClr val="accent1"/>
+          </a:lnRef>
+          <a:fillRef idx="0">
+            <a:schemeClr val="accent1"/>
+          </a:fillRef>
+          <a:effectRef idx="1">
+            <a:schemeClr val="accent1"/>
+          </a:effectRef>
+          <a:fontRef idx="minor">
+            <a:schemeClr val="tx1"/>
+          </a:fontRef>
+        </p:style>
+      </p:cxnSp>
+      <p:sp>
+        <p:nvSpPr>
+          <p:cNvPr id="3" name="TextBox 2">
+            <a:extLst>
+              <a:ext uri="{FF2B5EF4-FFF2-40B4-BE49-F238E27FC236}">
+                <a16:creationId xmlns:a16="http://schemas.microsoft.com/office/drawing/2014/main" id="{C432D393-917B-27D2-6BF8-92898F7C240A}"/>
+              </a:ext>
+            </a:extLst>
+          </p:cNvPr>
+          <p:cNvSpPr txBox="1"/>
+          <p:nvPr/>
+        </p:nvSpPr>
+        <p:spPr>
+          <a:xfrm>
+            <a:off x="7247860" y="5048584"/>
+            <a:ext cx="1631756" cy="369332"/>
+          </a:xfrm>
+          <a:prstGeom prst="rect">
+            <a:avLst/>
+          </a:prstGeom>
+          <a:noFill/>
+        </p:spPr>
+        <p:txBody>
+          <a:bodyPr wrap="square" rtlCol="0">
+            <a:spAutoFit/>
+          </a:bodyPr>
+          <a:lstStyle/>
+          <a:p>
+            <a:r>
+              <a:rPr lang="en-US" dirty="0"/>
+              <a:t>SevOne Server</a:t>
+            </a:r>
+          </a:p>
+        </p:txBody>
+      </p:sp>
+      <p:sp>
+        <p:nvSpPr>
+          <p:cNvPr id="10" name="TextBox 9">
+            <a:extLst>
+              <a:ext uri="{FF2B5EF4-FFF2-40B4-BE49-F238E27FC236}">
+                <a16:creationId xmlns:a16="http://schemas.microsoft.com/office/drawing/2014/main" id="{CBCCC191-525F-08FF-8B7B-F6971CDCD5F7}"/>
+              </a:ext>
+            </a:extLst>
+          </p:cNvPr>
+          <p:cNvSpPr txBox="1"/>
+          <p:nvPr/>
+        </p:nvSpPr>
+        <p:spPr>
+          <a:xfrm>
+            <a:off x="7242636" y="1772824"/>
+            <a:ext cx="1631756" cy="369332"/>
+          </a:xfrm>
+          <a:prstGeom prst="rect">
+            <a:avLst/>
+          </a:prstGeom>
+          <a:noFill/>
+        </p:spPr>
+        <p:txBody>
+          <a:bodyPr wrap="square" rtlCol="0">
+            <a:spAutoFit/>
+          </a:bodyPr>
+          <a:lstStyle/>
+          <a:p>
+            <a:r>
+              <a:rPr lang="en-US" dirty="0"/>
+              <a:t>Bob Shell</a:t>
+            </a:r>
+          </a:p>
+        </p:txBody>
+      </p:sp>
+    </p:spTree>
+    <p:extLst>
+      <p:ext uri="{BB962C8B-B14F-4D97-AF65-F5344CB8AC3E}">
+        <p14:creationId xmlns:p14="http://schemas.microsoft.com/office/powerpoint/2010/main" val="2220302221"/>
+      </p:ext>
+    </p:extLst>
+  </p:cSld>
+  <p:clrMapOvr>
+    <a:masterClrMapping/>
+  </p:clrMapOvr>
+</p:sld>
+</file>
+
+<file path=ppt/slides/slide2.xml><?xml version="1.0" encoding="utf-8"?>
+<p:sld xmlns:a="http://schemas.openxmlformats.org/drawingml/2006/main" xmlns:r="http://schemas.openxmlformats.org/officeDocument/2006/relationships" xmlns:p="http://schemas.openxmlformats.org/presentationml/2006/main">
+  <p:cSld>
+    <p:spTree>
+      <p:nvGrpSpPr>
+        <p:cNvPr id="1" name=""/>
+        <p:cNvGrpSpPr/>
+        <p:nvPr/>
+      </p:nvGrpSpPr>
+      <p:grpSpPr>
+        <a:xfrm>
+          <a:off x="0" y="0"/>
+          <a:ext cx="0" cy="0"/>
+          <a:chOff x="0" y="0"/>
+          <a:chExt cx="0" cy="0"/>
+        </a:xfrm>
+      </p:grpSpPr>
+      <p:sp>
+        <p:nvSpPr>
+          <p:cNvPr id="2" name="Title 1">
+            <a:extLst>
+              <a:ext uri="{FF2B5EF4-FFF2-40B4-BE49-F238E27FC236}">
+                <a16:creationId xmlns:a16="http://schemas.microsoft.com/office/drawing/2014/main" id="{D58D22AD-8BE0-090B-0936-3B10F865CAE7}"/>
+              </a:ext>
+            </a:extLst>
+          </p:cNvPr>
+          <p:cNvSpPr>
+            <a:spLocks noGrp="1"/>
+          </p:cNvSpPr>
+          <p:nvPr>
+            <p:ph type="title"/>
+          </p:nvPr>
+        </p:nvSpPr>
+        <p:spPr/>
+        <p:txBody>
+          <a:bodyPr/>
+          <a:lstStyle/>
+          <a:p>
+            <a:endParaRPr lang="en-US"/>
+          </a:p>
+        </p:txBody>
+      </p:sp>
+      <p:sp>
+        <p:nvSpPr>
+          <p:cNvPr id="3" name="Content Placeholder 2">
+            <a:extLst>
+              <a:ext uri="{FF2B5EF4-FFF2-40B4-BE49-F238E27FC236}">
+                <a16:creationId xmlns:a16="http://schemas.microsoft.com/office/drawing/2014/main" id="{47F79A88-5AB4-D666-FD8D-741A8B5A56F4}"/>
+              </a:ext>
+            </a:extLst>
+          </p:cNvPr>
+          <p:cNvSpPr>
+            <a:spLocks noGrp="1"/>
+          </p:cNvSpPr>
+          <p:nvPr>
+            <p:ph idx="1"/>
+          </p:nvPr>
+        </p:nvSpPr>
+        <p:spPr/>
+        <p:txBody>
+          <a:bodyPr/>
+          <a:lstStyle/>
+          <a:p>
+            <a:endParaRPr lang="en-US"/>
+          </a:p>
+        </p:txBody>
+      </p:sp>
+      <p:sp>
+        <p:nvSpPr>
+          <p:cNvPr id="4" name="Rectangle 3">
+            <a:extLst>
+              <a:ext uri="{FF2B5EF4-FFF2-40B4-BE49-F238E27FC236}">
+                <a16:creationId xmlns:a16="http://schemas.microsoft.com/office/drawing/2014/main" id="{A1B6BFD1-7E9D-B8EE-744A-27350D59C916}"/>
               </a:ext>
             </a:extLst>
           </p:cNvPr>
@@ -3723,16 +4196,16 @@
       </p:sp>
       <p:cxnSp>
         <p:nvCxnSpPr>
-          <p:cNvPr id="15" name="Straight Arrow Connector 14">
-            <a:extLst>
-              <a:ext uri="{FF2B5EF4-FFF2-40B4-BE49-F238E27FC236}">
-                <a16:creationId xmlns:a16="http://schemas.microsoft.com/office/drawing/2014/main" id="{82C6D207-F892-C7FF-F251-C157D3B2A353}"/>
+          <p:cNvPr id="5" name="Straight Arrow Connector 4">
+            <a:extLst>
+              <a:ext uri="{FF2B5EF4-FFF2-40B4-BE49-F238E27FC236}">
+                <a16:creationId xmlns:a16="http://schemas.microsoft.com/office/drawing/2014/main" id="{9025EC9B-A267-FCB2-EF5D-33683D1E7ECF}"/>
               </a:ext>
             </a:extLst>
           </p:cNvPr>
           <p:cNvCxnSpPr>
             <a:cxnSpLocks/>
-            <a:endCxn id="14" idx="0"/>
+            <a:endCxn id="4" idx="0"/>
           </p:cNvCxnSpPr>
           <p:nvPr/>
         </p:nvCxnSpPr>
@@ -3763,348 +4236,12 @@
           </a:fontRef>
         </p:style>
       </p:cxnSp>
-      <p:cxnSp>
-        <p:nvCxnSpPr>
-          <p:cNvPr id="17" name="Straight Arrow Connector 16">
-            <a:extLst>
-              <a:ext uri="{FF2B5EF4-FFF2-40B4-BE49-F238E27FC236}">
-                <a16:creationId xmlns:a16="http://schemas.microsoft.com/office/drawing/2014/main" id="{8076974C-F42F-4919-E125-3060C3E84D31}"/>
-              </a:ext>
-            </a:extLst>
-          </p:cNvPr>
-          <p:cNvCxnSpPr>
-            <a:cxnSpLocks/>
-          </p:cNvCxnSpPr>
-          <p:nvPr/>
-        </p:nvCxnSpPr>
-        <p:spPr>
-          <a:xfrm>
-            <a:off x="4826738" y="4180351"/>
-            <a:ext cx="0" cy="795686"/>
-          </a:xfrm>
-          <a:prstGeom prst="straightConnector1">
-            <a:avLst/>
-          </a:prstGeom>
-          <a:ln>
-            <a:tailEnd type="triangle"/>
-          </a:ln>
-        </p:spPr>
-        <p:style>
-          <a:lnRef idx="2">
-            <a:schemeClr val="accent1"/>
-          </a:lnRef>
-          <a:fillRef idx="0">
-            <a:schemeClr val="accent1"/>
-          </a:fillRef>
-          <a:effectRef idx="1">
-            <a:schemeClr val="accent1"/>
-          </a:effectRef>
-          <a:fontRef idx="minor">
-            <a:schemeClr val="tx1"/>
-          </a:fontRef>
-        </p:style>
-      </p:cxnSp>
-      <p:cxnSp>
-        <p:nvCxnSpPr>
-          <p:cNvPr id="19" name="Straight Arrow Connector 18">
-            <a:extLst>
-              <a:ext uri="{FF2B5EF4-FFF2-40B4-BE49-F238E27FC236}">
-                <a16:creationId xmlns:a16="http://schemas.microsoft.com/office/drawing/2014/main" id="{4FBBA4F8-9936-4228-3CDE-62B262641460}"/>
-              </a:ext>
-            </a:extLst>
-          </p:cNvPr>
-          <p:cNvCxnSpPr>
-            <a:cxnSpLocks/>
-          </p:cNvCxnSpPr>
-          <p:nvPr/>
-        </p:nvCxnSpPr>
-        <p:spPr>
-          <a:xfrm flipH="1">
-            <a:off x="6531491" y="4263483"/>
-            <a:ext cx="799658" cy="712554"/>
-          </a:xfrm>
-          <a:prstGeom prst="straightConnector1">
-            <a:avLst/>
-          </a:prstGeom>
-          <a:ln>
-            <a:tailEnd type="triangle"/>
-          </a:ln>
-        </p:spPr>
-        <p:style>
-          <a:lnRef idx="2">
-            <a:schemeClr val="accent1"/>
-          </a:lnRef>
-          <a:fillRef idx="0">
-            <a:schemeClr val="accent1"/>
-          </a:fillRef>
-          <a:effectRef idx="1">
-            <a:schemeClr val="accent1"/>
-          </a:effectRef>
-          <a:fontRef idx="minor">
-            <a:schemeClr val="tx1"/>
-          </a:fontRef>
-        </p:style>
-      </p:cxnSp>
-      <p:sp>
-        <p:nvSpPr>
-          <p:cNvPr id="20" name="Can 19">
-            <a:extLst>
-              <a:ext uri="{FF2B5EF4-FFF2-40B4-BE49-F238E27FC236}">
-                <a16:creationId xmlns:a16="http://schemas.microsoft.com/office/drawing/2014/main" id="{9252A2AE-66FE-8280-8B3B-0F9895A1E701}"/>
-              </a:ext>
-            </a:extLst>
-          </p:cNvPr>
-          <p:cNvSpPr/>
-          <p:nvPr/>
-        </p:nvSpPr>
-        <p:spPr>
-          <a:xfrm>
-            <a:off x="4267200" y="4976037"/>
-            <a:ext cx="2732568" cy="1456661"/>
-          </a:xfrm>
-          <a:prstGeom prst="can">
-            <a:avLst/>
-          </a:prstGeom>
-        </p:spPr>
-        <p:style>
-          <a:lnRef idx="2">
-            <a:schemeClr val="accent1">
-              <a:shade val="15000"/>
-            </a:schemeClr>
-          </a:lnRef>
-          <a:fillRef idx="1">
-            <a:schemeClr val="accent1"/>
-          </a:fillRef>
-          <a:effectRef idx="0">
-            <a:schemeClr val="accent1"/>
-          </a:effectRef>
-          <a:fontRef idx="minor">
-            <a:schemeClr val="lt1"/>
-          </a:fontRef>
-        </p:style>
-        <p:txBody>
-          <a:bodyPr rtlCol="0" anchor="ctr"/>
-          <a:lstStyle/>
-          <a:p>
-            <a:pPr algn="ctr"/>
-            <a:r>
-              <a:rPr lang="en-US" dirty="0" err="1"/>
-              <a:t>Mysql</a:t>
-            </a:r>
-            <a:r>
-              <a:rPr lang="en-US" dirty="0"/>
-              <a:t> DB</a:t>
-            </a:r>
-          </a:p>
-        </p:txBody>
-      </p:sp>
-      <p:sp>
-        <p:nvSpPr>
-          <p:cNvPr id="21" name="TextBox 20">
-            <a:extLst>
-              <a:ext uri="{FF2B5EF4-FFF2-40B4-BE49-F238E27FC236}">
-                <a16:creationId xmlns:a16="http://schemas.microsoft.com/office/drawing/2014/main" id="{33F61FA9-0ADD-D27D-90F4-3B4586406C27}"/>
-              </a:ext>
-            </a:extLst>
-          </p:cNvPr>
-          <p:cNvSpPr txBox="1"/>
-          <p:nvPr/>
-        </p:nvSpPr>
-        <p:spPr>
-          <a:xfrm>
-            <a:off x="4826739" y="4245281"/>
-            <a:ext cx="1022940" cy="646331"/>
-          </a:xfrm>
-          <a:prstGeom prst="rect">
-            <a:avLst/>
-          </a:prstGeom>
-          <a:noFill/>
-        </p:spPr>
-        <p:txBody>
-          <a:bodyPr wrap="square" rtlCol="0">
-            <a:spAutoFit/>
-          </a:bodyPr>
-          <a:lstStyle/>
-          <a:p>
-            <a:r>
-              <a:rPr lang="en-US" dirty="0"/>
-              <a:t>Select queries</a:t>
-            </a:r>
-          </a:p>
-        </p:txBody>
-      </p:sp>
-      <p:sp>
-        <p:nvSpPr>
-          <p:cNvPr id="22" name="TextBox 21">
-            <a:extLst>
-              <a:ext uri="{FF2B5EF4-FFF2-40B4-BE49-F238E27FC236}">
-                <a16:creationId xmlns:a16="http://schemas.microsoft.com/office/drawing/2014/main" id="{7761422C-1CBE-A5D0-9B18-26D1D4388CE4}"/>
-              </a:ext>
-            </a:extLst>
-          </p:cNvPr>
-          <p:cNvSpPr txBox="1"/>
-          <p:nvPr/>
-        </p:nvSpPr>
-        <p:spPr>
-          <a:xfrm>
-            <a:off x="6539023" y="4263483"/>
-            <a:ext cx="1022940" cy="646331"/>
-          </a:xfrm>
-          <a:prstGeom prst="rect">
-            <a:avLst/>
-          </a:prstGeom>
-          <a:noFill/>
-        </p:spPr>
-        <p:txBody>
-          <a:bodyPr wrap="square" rtlCol="0">
-            <a:spAutoFit/>
-          </a:bodyPr>
-          <a:lstStyle/>
-          <a:p>
-            <a:r>
-              <a:rPr lang="en-US" dirty="0"/>
-              <a:t>insert queries</a:t>
-            </a:r>
-          </a:p>
-        </p:txBody>
-      </p:sp>
-      <p:cxnSp>
-        <p:nvCxnSpPr>
-          <p:cNvPr id="23" name="Straight Arrow Connector 22">
-            <a:extLst>
-              <a:ext uri="{FF2B5EF4-FFF2-40B4-BE49-F238E27FC236}">
-                <a16:creationId xmlns:a16="http://schemas.microsoft.com/office/drawing/2014/main" id="{02EBA294-E3DF-9411-FE6E-F168FCB08EF9}"/>
-              </a:ext>
-            </a:extLst>
-          </p:cNvPr>
-          <p:cNvCxnSpPr>
-            <a:cxnSpLocks/>
-          </p:cNvCxnSpPr>
-          <p:nvPr/>
-        </p:nvCxnSpPr>
-        <p:spPr>
-          <a:xfrm flipV="1">
-            <a:off x="4700034" y="2909780"/>
-            <a:ext cx="126704" cy="536926"/>
-          </a:xfrm>
-          <a:prstGeom prst="straightConnector1">
-            <a:avLst/>
-          </a:prstGeom>
-          <a:ln>
-            <a:tailEnd type="triangle"/>
-          </a:ln>
-        </p:spPr>
-        <p:style>
-          <a:lnRef idx="2">
-            <a:schemeClr val="accent1"/>
-          </a:lnRef>
-          <a:fillRef idx="0">
-            <a:schemeClr val="accent1"/>
-          </a:fillRef>
-          <a:effectRef idx="1">
-            <a:schemeClr val="accent1"/>
-          </a:effectRef>
-          <a:fontRef idx="minor">
-            <a:schemeClr val="tx1"/>
-          </a:fontRef>
-        </p:style>
-      </p:cxnSp>
-      <p:cxnSp>
-        <p:nvCxnSpPr>
-          <p:cNvPr id="25" name="Straight Arrow Connector 24">
-            <a:extLst>
-              <a:ext uri="{FF2B5EF4-FFF2-40B4-BE49-F238E27FC236}">
-                <a16:creationId xmlns:a16="http://schemas.microsoft.com/office/drawing/2014/main" id="{2DD92A26-4EB2-157F-4E43-9D4B40DC587A}"/>
-              </a:ext>
-            </a:extLst>
-          </p:cNvPr>
-          <p:cNvCxnSpPr>
-            <a:cxnSpLocks/>
-          </p:cNvCxnSpPr>
-          <p:nvPr/>
-        </p:nvCxnSpPr>
-        <p:spPr>
-          <a:xfrm flipH="1">
-            <a:off x="2806995" y="2690037"/>
-            <a:ext cx="1456660" cy="0"/>
-          </a:xfrm>
-          <a:prstGeom prst="straightConnector1">
-            <a:avLst/>
-          </a:prstGeom>
-          <a:ln>
-            <a:tailEnd type="triangle"/>
-          </a:ln>
-        </p:spPr>
-        <p:style>
-          <a:lnRef idx="2">
-            <a:schemeClr val="accent1"/>
-          </a:lnRef>
-          <a:fillRef idx="0">
-            <a:schemeClr val="accent1"/>
-          </a:fillRef>
-          <a:effectRef idx="1">
-            <a:schemeClr val="accent1"/>
-          </a:effectRef>
-          <a:fontRef idx="minor">
-            <a:schemeClr val="tx1"/>
-          </a:fontRef>
-        </p:style>
-      </p:cxnSp>
-      <p:sp>
-        <p:nvSpPr>
-          <p:cNvPr id="32" name="Rectangle 31">
-            <a:extLst>
-              <a:ext uri="{FF2B5EF4-FFF2-40B4-BE49-F238E27FC236}">
-                <a16:creationId xmlns:a16="http://schemas.microsoft.com/office/drawing/2014/main" id="{E687BC13-71D2-1351-311D-C559B987C557}"/>
-              </a:ext>
-            </a:extLst>
-          </p:cNvPr>
-          <p:cNvSpPr/>
-          <p:nvPr/>
-        </p:nvSpPr>
-        <p:spPr>
-          <a:xfrm>
-            <a:off x="6313967" y="2161076"/>
-            <a:ext cx="1701210" cy="738945"/>
-          </a:xfrm>
-          <a:prstGeom prst="rect">
-            <a:avLst/>
-          </a:prstGeom>
-        </p:spPr>
-        <p:style>
-          <a:lnRef idx="2">
-            <a:schemeClr val="accent1">
-              <a:shade val="15000"/>
-            </a:schemeClr>
-          </a:lnRef>
-          <a:fillRef idx="1">
-            <a:schemeClr val="accent1"/>
-          </a:fillRef>
-          <a:effectRef idx="0">
-            <a:schemeClr val="accent1"/>
-          </a:effectRef>
-          <a:fontRef idx="minor">
-            <a:schemeClr val="lt1"/>
-          </a:fontRef>
-        </p:style>
-        <p:txBody>
-          <a:bodyPr rtlCol="0" anchor="ctr"/>
-          <a:lstStyle/>
-          <a:p>
-            <a:pPr algn="ctr"/>
-            <a:r>
-              <a:rPr lang="en-US" dirty="0"/>
-              <a:t>API Expert Agent [ Bob Mode] </a:t>
-            </a:r>
-          </a:p>
-        </p:txBody>
-      </p:sp>
-      <p:sp>
-        <p:nvSpPr>
-          <p:cNvPr id="33" name="Rectangle 32">
-            <a:extLst>
-              <a:ext uri="{FF2B5EF4-FFF2-40B4-BE49-F238E27FC236}">
-                <a16:creationId xmlns:a16="http://schemas.microsoft.com/office/drawing/2014/main" id="{07617570-B949-8F89-0199-AFFD91BADB2C}"/>
+      <p:sp>
+        <p:nvSpPr>
+          <p:cNvPr id="6" name="Rectangle 5">
+            <a:extLst>
+              <a:ext uri="{FF2B5EF4-FFF2-40B4-BE49-F238E27FC236}">
+                <a16:creationId xmlns:a16="http://schemas.microsoft.com/office/drawing/2014/main" id="{9C8AA81B-79DA-39D5-1423-831270BADF2E}"/>
               </a:ext>
             </a:extLst>
           </p:cNvPr>
@@ -4151,16 +4288,15 @@
       </p:sp>
       <p:cxnSp>
         <p:nvCxnSpPr>
-          <p:cNvPr id="34" name="Straight Arrow Connector 33">
-            <a:extLst>
-              <a:ext uri="{FF2B5EF4-FFF2-40B4-BE49-F238E27FC236}">
-                <a16:creationId xmlns:a16="http://schemas.microsoft.com/office/drawing/2014/main" id="{D1A22DAC-99B0-D651-6B08-F4EA33F2AC1D}"/>
+          <p:cNvPr id="7" name="Straight Arrow Connector 6">
+            <a:extLst>
+              <a:ext uri="{FF2B5EF4-FFF2-40B4-BE49-F238E27FC236}">
+                <a16:creationId xmlns:a16="http://schemas.microsoft.com/office/drawing/2014/main" id="{7DD9B85A-1855-EB1B-3A89-D4D05B0F5451}"/>
               </a:ext>
             </a:extLst>
           </p:cNvPr>
           <p:cNvCxnSpPr>
             <a:cxnSpLocks/>
-            <a:endCxn id="32" idx="0"/>
           </p:cNvCxnSpPr>
           <p:nvPr/>
         </p:nvCxnSpPr>
@@ -4191,10 +4327,59 @@
           </a:fontRef>
         </p:style>
       </p:cxnSp>
+      <p:sp>
+        <p:nvSpPr>
+          <p:cNvPr id="8" name="Rectangle 7">
+            <a:extLst>
+              <a:ext uri="{FF2B5EF4-FFF2-40B4-BE49-F238E27FC236}">
+                <a16:creationId xmlns:a16="http://schemas.microsoft.com/office/drawing/2014/main" id="{2CAAD697-D9E3-AFB9-3B86-050343DBE26D}"/>
+              </a:ext>
+            </a:extLst>
+          </p:cNvPr>
+          <p:cNvSpPr/>
+          <p:nvPr/>
+        </p:nvSpPr>
+        <p:spPr>
+          <a:xfrm>
+            <a:off x="6313967" y="2161076"/>
+            <a:ext cx="1701210" cy="738945"/>
+          </a:xfrm>
+          <a:prstGeom prst="rect">
+            <a:avLst/>
+          </a:prstGeom>
+        </p:spPr>
+        <p:style>
+          <a:lnRef idx="2">
+            <a:schemeClr val="accent1">
+              <a:shade val="15000"/>
+            </a:schemeClr>
+          </a:lnRef>
+          <a:fillRef idx="1">
+            <a:schemeClr val="accent1"/>
+          </a:fillRef>
+          <a:effectRef idx="0">
+            <a:schemeClr val="accent1"/>
+          </a:effectRef>
+          <a:fontRef idx="minor">
+            <a:schemeClr val="lt1"/>
+          </a:fontRef>
+        </p:style>
+        <p:txBody>
+          <a:bodyPr rtlCol="0" anchor="ctr"/>
+          <a:lstStyle/>
+          <a:p>
+            <a:pPr algn="ctr"/>
+            <a:r>
+              <a:rPr lang="en-US" dirty="0"/>
+              <a:t>API Expert Agent [ Bob Mode] </a:t>
+            </a:r>
+          </a:p>
+        </p:txBody>
+      </p:sp>
     </p:spTree>
     <p:extLst>
       <p:ext uri="{BB962C8B-B14F-4D97-AF65-F5344CB8AC3E}">
-        <p14:creationId xmlns:p14="http://schemas.microsoft.com/office/powerpoint/2010/main" val="2220302221"/>
+        <p14:creationId xmlns:p14="http://schemas.microsoft.com/office/powerpoint/2010/main" val="3810247635"/>
       </p:ext>
     </p:extLst>
   </p:cSld>

</xml_diff>